<commit_message>
Software Updates - Fix the PID error distribution values to be 2 to 16 instead of 0 to 14 - Add lost code - Increase rotate cases
</commit_message>
<xml_diff>
--- a/SoftwareDesign/LineFollowerV1.0/StateMachine/PID.pptx
+++ b/SoftwareDesign/LineFollowerV1.0/StateMachine/PID.pptx
@@ -106,6 +106,11 @@
       </a:defRPr>
     </a:lvl9pPr>
   </p:defaultTextStyle>
+  <p:extLst>
+    <p:ext uri="{EFAFB233-063F-42B5-8137-9DF3F51BA10A}">
+      <p15:sldGuideLst xmlns:p15="http://schemas.microsoft.com/office/powerpoint/2012/main"/>
+    </p:ext>
+  </p:extLst>
 </p:presentation>
 </file>
 
@@ -280,7 +285,7 @@
           <a:p>
             <a:fld id="{5DCBB9FE-B992-4251-8BBE-8A3EC87EE165}" type="datetimeFigureOut">
               <a:rPr lang="en-US" smtClean="0"/>
-              <a:t>9/20/2025</a:t>
+              <a:t>11/7/2025</a:t>
             </a:fld>
             <a:endParaRPr lang="en-US"/>
           </a:p>
@@ -592,7 +597,7 @@
           <a:p>
             <a:fld id="{5DCBB9FE-B992-4251-8BBE-8A3EC87EE165}" type="datetimeFigureOut">
               <a:rPr lang="en-US" smtClean="0"/>
-              <a:t>9/20/2025</a:t>
+              <a:t>11/7/2025</a:t>
             </a:fld>
             <a:endParaRPr lang="en-US"/>
           </a:p>
@@ -814,7 +819,7 @@
           <a:p>
             <a:fld id="{5DCBB9FE-B992-4251-8BBE-8A3EC87EE165}" type="datetimeFigureOut">
               <a:rPr lang="en-US" smtClean="0"/>
-              <a:t>9/20/2025</a:t>
+              <a:t>11/7/2025</a:t>
             </a:fld>
             <a:endParaRPr lang="en-US"/>
           </a:p>
@@ -1105,7 +1110,7 @@
           <a:p>
             <a:fld id="{5DCBB9FE-B992-4251-8BBE-8A3EC87EE165}" type="datetimeFigureOut">
               <a:rPr lang="en-US" smtClean="0"/>
-              <a:t>9/20/2025</a:t>
+              <a:t>11/7/2025</a:t>
             </a:fld>
             <a:endParaRPr lang="en-US"/>
           </a:p>
@@ -1559,7 +1564,7 @@
           <a:p>
             <a:fld id="{5DCBB9FE-B992-4251-8BBE-8A3EC87EE165}" type="datetimeFigureOut">
               <a:rPr lang="en-US" smtClean="0"/>
-              <a:t>9/20/2025</a:t>
+              <a:t>11/7/2025</a:t>
             </a:fld>
             <a:endParaRPr lang="en-US"/>
           </a:p>
@@ -2135,7 +2140,7 @@
           <a:p>
             <a:fld id="{5DCBB9FE-B992-4251-8BBE-8A3EC87EE165}" type="datetimeFigureOut">
               <a:rPr lang="en-US" smtClean="0"/>
-              <a:t>9/20/2025</a:t>
+              <a:t>11/7/2025</a:t>
             </a:fld>
             <a:endParaRPr lang="en-US"/>
           </a:p>
@@ -2987,7 +2992,7 @@
           <a:p>
             <a:fld id="{5DCBB9FE-B992-4251-8BBE-8A3EC87EE165}" type="datetimeFigureOut">
               <a:rPr lang="en-US" smtClean="0"/>
-              <a:t>9/20/2025</a:t>
+              <a:t>11/7/2025</a:t>
             </a:fld>
             <a:endParaRPr lang="en-US"/>
           </a:p>
@@ -3192,7 +3197,7 @@
           <a:p>
             <a:fld id="{5DCBB9FE-B992-4251-8BBE-8A3EC87EE165}" type="datetimeFigureOut">
               <a:rPr lang="en-US" smtClean="0"/>
-              <a:t>9/20/2025</a:t>
+              <a:t>11/7/2025</a:t>
             </a:fld>
             <a:endParaRPr lang="en-US"/>
           </a:p>
@@ -3406,7 +3411,7 @@
           <a:p>
             <a:fld id="{5DCBB9FE-B992-4251-8BBE-8A3EC87EE165}" type="datetimeFigureOut">
               <a:rPr lang="en-US" smtClean="0"/>
-              <a:t>9/20/2025</a:t>
+              <a:t>11/7/2025</a:t>
             </a:fld>
             <a:endParaRPr lang="en-US"/>
           </a:p>
@@ -3611,7 +3616,7 @@
           <a:p>
             <a:fld id="{5DCBB9FE-B992-4251-8BBE-8A3EC87EE165}" type="datetimeFigureOut">
               <a:rPr lang="en-US" smtClean="0"/>
-              <a:t>9/20/2025</a:t>
+              <a:t>11/7/2025</a:t>
             </a:fld>
             <a:endParaRPr lang="en-US"/>
           </a:p>
@@ -3891,7 +3896,7 @@
           <a:p>
             <a:fld id="{5DCBB9FE-B992-4251-8BBE-8A3EC87EE165}" type="datetimeFigureOut">
               <a:rPr lang="en-US" smtClean="0"/>
-              <a:t>9/20/2025</a:t>
+              <a:t>11/7/2025</a:t>
             </a:fld>
             <a:endParaRPr lang="en-US"/>
           </a:p>
@@ -4158,7 +4163,7 @@
           <a:p>
             <a:fld id="{5DCBB9FE-B992-4251-8BBE-8A3EC87EE165}" type="datetimeFigureOut">
               <a:rPr lang="en-US" smtClean="0"/>
-              <a:t>9/20/2025</a:t>
+              <a:t>11/7/2025</a:t>
             </a:fld>
             <a:endParaRPr lang="en-US"/>
           </a:p>
@@ -4573,7 +4578,7 @@
           <a:p>
             <a:fld id="{5DCBB9FE-B992-4251-8BBE-8A3EC87EE165}" type="datetimeFigureOut">
               <a:rPr lang="en-US" smtClean="0"/>
-              <a:t>9/20/2025</a:t>
+              <a:t>11/7/2025</a:t>
             </a:fld>
             <a:endParaRPr lang="en-US"/>
           </a:p>
@@ -4721,7 +4726,7 @@
           <a:p>
             <a:fld id="{5DCBB9FE-B992-4251-8BBE-8A3EC87EE165}" type="datetimeFigureOut">
               <a:rPr lang="en-US" smtClean="0"/>
-              <a:t>9/20/2025</a:t>
+              <a:t>11/7/2025</a:t>
             </a:fld>
             <a:endParaRPr lang="en-US"/>
           </a:p>
@@ -4846,7 +4851,7 @@
           <a:p>
             <a:fld id="{5DCBB9FE-B992-4251-8BBE-8A3EC87EE165}" type="datetimeFigureOut">
               <a:rPr lang="en-US" smtClean="0"/>
-              <a:t>9/20/2025</a:t>
+              <a:t>11/7/2025</a:t>
             </a:fld>
             <a:endParaRPr lang="en-US"/>
           </a:p>
@@ -5125,7 +5130,7 @@
           <a:p>
             <a:fld id="{5DCBB9FE-B992-4251-8BBE-8A3EC87EE165}" type="datetimeFigureOut">
               <a:rPr lang="en-US" smtClean="0"/>
-              <a:t>9/20/2025</a:t>
+              <a:t>11/7/2025</a:t>
             </a:fld>
             <a:endParaRPr lang="en-US"/>
           </a:p>
@@ -5437,7 +5442,7 @@
           <a:p>
             <a:fld id="{5DCBB9FE-B992-4251-8BBE-8A3EC87EE165}" type="datetimeFigureOut">
               <a:rPr lang="en-US" smtClean="0"/>
-              <a:t>9/20/2025</a:t>
+              <a:t>11/7/2025</a:t>
             </a:fld>
             <a:endParaRPr lang="en-US"/>
           </a:p>
@@ -5690,7 +5695,7 @@
           <a:p>
             <a:fld id="{5DCBB9FE-B992-4251-8BBE-8A3EC87EE165}" type="datetimeFigureOut">
               <a:rPr lang="en-US" smtClean="0"/>
-              <a:t>9/20/2025</a:t>
+              <a:t>11/7/2025</a:t>
             </a:fld>
             <a:endParaRPr lang="en-US"/>
           </a:p>
@@ -6287,10 +6292,26 @@
                   <a:srgbClr val="0070C0"/>
                 </a:solidFill>
               </a:rPr>
-              <a:t>peed range 800</a:t>
-            </a:r>
-            <a:r>
-              <a:rPr lang="en-US" sz="1200" cap="none" dirty="0" smtClean="0">
+              <a:t>peed </a:t>
+            </a:r>
+            <a:r>
+              <a:rPr lang="en-US" cap="none" smtClean="0">
+                <a:solidFill>
+                  <a:srgbClr val="0070C0"/>
+                </a:solidFill>
+              </a:rPr>
+              <a:t>range </a:t>
+            </a:r>
+            <a:r>
+              <a:rPr lang="en-US" cap="none" smtClean="0">
+                <a:solidFill>
+                  <a:srgbClr val="0070C0"/>
+                </a:solidFill>
+              </a:rPr>
+              <a:t>700</a:t>
+            </a:r>
+            <a:r>
+              <a:rPr lang="en-US" sz="1200" cap="none" smtClean="0">
                 <a:solidFill>
                   <a:srgbClr val="0070C0"/>
                 </a:solidFill>
@@ -6298,12 +6319,20 @@
               <a:t>Min</a:t>
             </a:r>
             <a:r>
+              <a:rPr lang="en-US" cap="none" smtClean="0">
+                <a:solidFill>
+                  <a:srgbClr val="0070C0"/>
+                </a:solidFill>
+              </a:rPr>
+              <a:t> </a:t>
+            </a:r>
+            <a:r>
               <a:rPr lang="en-US" cap="none" dirty="0" smtClean="0">
                 <a:solidFill>
                   <a:srgbClr val="0070C0"/>
                 </a:solidFill>
               </a:rPr>
-              <a:t> – 1200</a:t>
+              <a:t>– 1200</a:t>
             </a:r>
             <a:r>
               <a:rPr lang="en-US" sz="1100" cap="none" dirty="0" smtClean="0">
@@ -6327,7 +6356,9 @@
             <a:r>
               <a:rPr lang="en-US" cap="none" dirty="0" smtClean="0">
                 <a:solidFill>
-                  <a:srgbClr val="FFC000"/>
+                  <a:schemeClr val="accent6">
+                    <a:lumMod val="50000"/>
+                  </a:schemeClr>
                 </a:solidFill>
               </a:rPr>
               <a:t>Sensor Reading(1-2-4-8-16-32-64-128) </a:t>
@@ -6349,7 +6380,15 @@
                   <a:srgbClr val="FF0000"/>
                 </a:solidFill>
               </a:rPr>
-              <a:t>rror Range (-7</a:t>
+              <a:t>rror Range </a:t>
+            </a:r>
+            <a:r>
+              <a:rPr lang="en-US" cap="none" dirty="0" smtClean="0">
+                <a:solidFill>
+                  <a:srgbClr val="FF0000"/>
+                </a:solidFill>
+              </a:rPr>
+              <a:t>(-7</a:t>
             </a:r>
             <a:r>
               <a:rPr lang="en-US" sz="1100" cap="none" dirty="0" smtClean="0">
@@ -6365,7 +6404,23 @@
                   <a:srgbClr val="FF0000"/>
                 </a:solidFill>
               </a:rPr>
-              <a:t> -&gt; 7</a:t>
+              <a:t> </a:t>
+            </a:r>
+            <a:r>
+              <a:rPr lang="en-US" cap="none" dirty="0" smtClean="0">
+                <a:solidFill>
+                  <a:srgbClr val="FF0000"/>
+                </a:solidFill>
+              </a:rPr>
+              <a:t>-&gt; </a:t>
+            </a:r>
+            <a:r>
+              <a:rPr lang="en-US" cap="none" dirty="0" smtClean="0">
+                <a:solidFill>
+                  <a:srgbClr val="FF0000"/>
+                </a:solidFill>
+              </a:rPr>
+              <a:t>7</a:t>
             </a:r>
             <a:r>
               <a:rPr lang="en-US" sz="1050" cap="none" dirty="0" smtClean="0">
@@ -6381,7 +6436,15 @@
                   <a:srgbClr val="FF0000"/>
                 </a:solidFill>
               </a:rPr>
-              <a:t> )</a:t>
+              <a:t> </a:t>
+            </a:r>
+            <a:r>
+              <a:rPr lang="en-US" cap="none" dirty="0" smtClean="0">
+                <a:solidFill>
+                  <a:srgbClr val="FF0000"/>
+                </a:solidFill>
+              </a:rPr>
+              <a:t>)</a:t>
             </a:r>
           </a:p>
           <a:p>
@@ -7008,14 +7071,118 @@
                     <a:r>
                       <a:rPr lang="en-US" dirty="0" smtClean="0">
                         <a:solidFill>
-                          <a:srgbClr val="FFC000"/>
+                          <a:schemeClr val="accent6">
+                            <a:lumMod val="50000"/>
+                          </a:schemeClr>
                         </a:solidFill>
                       </a:rPr>
-                      <a:t>0       2	    4	      6	8	  10	    12    14</a:t>
+                      <a:t>2       4</a:t>
+                    </a:r>
+                    <a:r>
+                      <a:rPr lang="en-US" dirty="0" smtClean="0">
+                        <a:solidFill>
+                          <a:schemeClr val="accent6">
+                            <a:lumMod val="50000"/>
+                          </a:schemeClr>
+                        </a:solidFill>
+                      </a:rPr>
+                      <a:t>	    </a:t>
+                    </a:r>
+                    <a:r>
+                      <a:rPr lang="en-US" dirty="0" smtClean="0">
+                        <a:solidFill>
+                          <a:schemeClr val="accent6">
+                            <a:lumMod val="50000"/>
+                          </a:schemeClr>
+                        </a:solidFill>
+                      </a:rPr>
+                      <a:t>6</a:t>
+                    </a:r>
+                    <a:r>
+                      <a:rPr lang="en-US" dirty="0" smtClean="0">
+                        <a:solidFill>
+                          <a:schemeClr val="accent6">
+                            <a:lumMod val="50000"/>
+                          </a:schemeClr>
+                        </a:solidFill>
+                      </a:rPr>
+                      <a:t>	      </a:t>
+                    </a:r>
+                    <a:r>
+                      <a:rPr lang="en-US" dirty="0" smtClean="0">
+                        <a:solidFill>
+                          <a:schemeClr val="accent6">
+                            <a:lumMod val="50000"/>
+                          </a:schemeClr>
+                        </a:solidFill>
+                      </a:rPr>
+                      <a:t>8</a:t>
+                    </a:r>
+                    <a:r>
+                      <a:rPr lang="en-US" dirty="0" smtClean="0">
+                        <a:solidFill>
+                          <a:schemeClr val="accent6">
+                            <a:lumMod val="50000"/>
+                          </a:schemeClr>
+                        </a:solidFill>
+                      </a:rPr>
+                      <a:t>	</a:t>
+                    </a:r>
+                    <a:r>
+                      <a:rPr lang="en-US" dirty="0" smtClean="0">
+                        <a:solidFill>
+                          <a:schemeClr val="accent6">
+                            <a:lumMod val="50000"/>
+                          </a:schemeClr>
+                        </a:solidFill>
+                      </a:rPr>
+                      <a:t>10</a:t>
+                    </a:r>
+                    <a:r>
+                      <a:rPr lang="en-US" dirty="0" smtClean="0">
+                        <a:solidFill>
+                          <a:schemeClr val="accent6">
+                            <a:lumMod val="50000"/>
+                          </a:schemeClr>
+                        </a:solidFill>
+                      </a:rPr>
+                      <a:t>	  </a:t>
+                    </a:r>
+                    <a:r>
+                      <a:rPr lang="en-US" dirty="0" smtClean="0">
+                        <a:solidFill>
+                          <a:schemeClr val="accent6">
+                            <a:lumMod val="50000"/>
+                          </a:schemeClr>
+                        </a:solidFill>
+                      </a:rPr>
+                      <a:t>12</a:t>
+                    </a:r>
+                    <a:r>
+                      <a:rPr lang="en-US" dirty="0" smtClean="0">
+                        <a:solidFill>
+                          <a:schemeClr val="accent6">
+                            <a:lumMod val="50000"/>
+                          </a:schemeClr>
+                        </a:solidFill>
+                      </a:rPr>
+                      <a:t>	    </a:t>
+                    </a:r>
+                    <a:r>
+                      <a:rPr lang="en-US" dirty="0" smtClean="0">
+                        <a:solidFill>
+                          <a:schemeClr val="accent6">
+                            <a:lumMod val="50000"/>
+                          </a:schemeClr>
+                        </a:solidFill>
+                      </a:rPr>
+                      <a:t>14    16</a:t>
                     </a:r>
                     <a:endParaRPr lang="en-US" dirty="0">
                       <a:solidFill>
-                        <a:srgbClr val="FFC000"/>
+                        <a:schemeClr val="accent6">
+                          <a:lumMod val="50000"/>
+                        </a:schemeClr>
                       </a:solidFill>
                     </a:endParaRPr>
                   </a:p>

</xml_diff>